<commit_message>
readme 수정 및 jira chatbot 기획 초안 추가
</commit_message>
<xml_diff>
--- a/기획/JIRA 챗봇 기획안.pptx
+++ b/기획/JIRA 챗봇 기획안.pptx
@@ -126,342 +126,6 @@
 <file path=ppt/changesInfos/changesInfo1.xml><?xml version="1.0" encoding="utf-8"?>
 <pc:chgInfo xmlns:a="http://schemas.openxmlformats.org/drawingml/2006/main" xmlns:r="http://schemas.openxmlformats.org/officeDocument/2006/relationships" xmlns:ac="http://schemas.microsoft.com/office/drawing/2013/main/command" xmlns:pc="http://schemas.microsoft.com/office/powerpoint/2013/main/command">
   <pc:docChgLst>
-    <pc:chgData name="기일 권" userId="2ef98fef2c7306f1" providerId="LiveId" clId="{08ECA750-B2CA-48AB-A58D-3D63F452242C}"/>
-    <pc:docChg chg="undo custSel addSld modSld">
-      <pc:chgData name="기일 권" userId="2ef98fef2c7306f1" providerId="LiveId" clId="{08ECA750-B2CA-48AB-A58D-3D63F452242C}" dt="2023-11-30T04:00:31.099" v="318"/>
-      <pc:docMkLst>
-        <pc:docMk/>
-      </pc:docMkLst>
-      <pc:sldChg chg="modSp mod">
-        <pc:chgData name="기일 권" userId="2ef98fef2c7306f1" providerId="LiveId" clId="{08ECA750-B2CA-48AB-A58D-3D63F452242C}" dt="2023-11-30T03:55:51.905" v="285" actId="122"/>
-        <pc:sldMkLst>
-          <pc:docMk/>
-          <pc:sldMk cId="3569210928" sldId="256"/>
-        </pc:sldMkLst>
-        <pc:spChg chg="mod">
-          <ac:chgData name="기일 권" userId="2ef98fef2c7306f1" providerId="LiveId" clId="{08ECA750-B2CA-48AB-A58D-3D63F452242C}" dt="2023-11-30T03:55:40.568" v="283" actId="255"/>
-          <ac:spMkLst>
-            <pc:docMk/>
-            <pc:sldMk cId="3569210928" sldId="256"/>
-            <ac:spMk id="2" creationId="{00000000-0000-0000-0000-000000000000}"/>
-          </ac:spMkLst>
-        </pc:spChg>
-        <pc:spChg chg="mod">
-          <ac:chgData name="기일 권" userId="2ef98fef2c7306f1" providerId="LiveId" clId="{08ECA750-B2CA-48AB-A58D-3D63F452242C}" dt="2023-11-30T03:55:51.905" v="285" actId="122"/>
-          <ac:spMkLst>
-            <pc:docMk/>
-            <pc:sldMk cId="3569210928" sldId="256"/>
-            <ac:spMk id="6" creationId="{C967072B-F25C-AC0D-F3A6-8FE1166ACA47}"/>
-          </ac:spMkLst>
-        </pc:spChg>
-      </pc:sldChg>
-      <pc:sldChg chg="modSp mod">
-        <pc:chgData name="기일 권" userId="2ef98fef2c7306f1" providerId="LiveId" clId="{08ECA750-B2CA-48AB-A58D-3D63F452242C}" dt="2023-11-30T03:56:10.509" v="288" actId="122"/>
-        <pc:sldMkLst>
-          <pc:docMk/>
-          <pc:sldMk cId="99140326" sldId="257"/>
-        </pc:sldMkLst>
-        <pc:spChg chg="mod">
-          <ac:chgData name="기일 권" userId="2ef98fef2c7306f1" providerId="LiveId" clId="{08ECA750-B2CA-48AB-A58D-3D63F452242C}" dt="2023-11-30T03:56:00.074" v="286" actId="255"/>
-          <ac:spMkLst>
-            <pc:docMk/>
-            <pc:sldMk cId="99140326" sldId="257"/>
-            <ac:spMk id="5" creationId="{90084524-CC88-D85E-32D8-6B06B0BA79D5}"/>
-          </ac:spMkLst>
-        </pc:spChg>
-        <pc:spChg chg="mod">
-          <ac:chgData name="기일 권" userId="2ef98fef2c7306f1" providerId="LiveId" clId="{08ECA750-B2CA-48AB-A58D-3D63F452242C}" dt="2023-11-30T03:56:10.509" v="288" actId="122"/>
-          <ac:spMkLst>
-            <pc:docMk/>
-            <pc:sldMk cId="99140326" sldId="257"/>
-            <ac:spMk id="6" creationId="{6AD760A5-771A-9EC6-F300-2A18AF3EAD3B}"/>
-          </ac:spMkLst>
-        </pc:spChg>
-        <pc:graphicFrameChg chg="mod modGraphic">
-          <ac:chgData name="기일 권" userId="2ef98fef2c7306f1" providerId="LiveId" clId="{08ECA750-B2CA-48AB-A58D-3D63F452242C}" dt="2023-11-30T03:54:58.196" v="216" actId="20577"/>
-          <ac:graphicFrameMkLst>
-            <pc:docMk/>
-            <pc:sldMk cId="99140326" sldId="257"/>
-            <ac:graphicFrameMk id="12" creationId="{69D47D66-BDAC-B7B6-9634-FDE8CE74C23B}"/>
-          </ac:graphicFrameMkLst>
-        </pc:graphicFrameChg>
-      </pc:sldChg>
-      <pc:sldChg chg="modSp mod">
-        <pc:chgData name="기일 권" userId="2ef98fef2c7306f1" providerId="LiveId" clId="{08ECA750-B2CA-48AB-A58D-3D63F452242C}" dt="2023-11-30T03:59:44.851" v="312" actId="207"/>
-        <pc:sldMkLst>
-          <pc:docMk/>
-          <pc:sldMk cId="883637149" sldId="258"/>
-        </pc:sldMkLst>
-        <pc:spChg chg="mod">
-          <ac:chgData name="기일 권" userId="2ef98fef2c7306f1" providerId="LiveId" clId="{08ECA750-B2CA-48AB-A58D-3D63F452242C}" dt="2023-11-30T03:59:44.851" v="312" actId="207"/>
-          <ac:spMkLst>
-            <pc:docMk/>
-            <pc:sldMk cId="883637149" sldId="258"/>
-            <ac:spMk id="3" creationId="{B8E5EDF5-1D07-0FF7-846E-CC438A46C07D}"/>
-          </ac:spMkLst>
-        </pc:spChg>
-        <pc:spChg chg="mod">
-          <ac:chgData name="기일 권" userId="2ef98fef2c7306f1" providerId="LiveId" clId="{08ECA750-B2CA-48AB-A58D-3D63F452242C}" dt="2023-11-30T03:59:44.851" v="312" actId="207"/>
-          <ac:spMkLst>
-            <pc:docMk/>
-            <pc:sldMk cId="883637149" sldId="258"/>
-            <ac:spMk id="4" creationId="{9A86D59B-7DE3-4AC3-BFE0-CF56B118FB3A}"/>
-          </ac:spMkLst>
-        </pc:spChg>
-        <pc:spChg chg="mod">
-          <ac:chgData name="기일 권" userId="2ef98fef2c7306f1" providerId="LiveId" clId="{08ECA750-B2CA-48AB-A58D-3D63F452242C}" dt="2023-11-30T03:56:22.986" v="289" actId="255"/>
-          <ac:spMkLst>
-            <pc:docMk/>
-            <pc:sldMk cId="883637149" sldId="258"/>
-            <ac:spMk id="5" creationId="{90084524-CC88-D85E-32D8-6B06B0BA79D5}"/>
-          </ac:spMkLst>
-        </pc:spChg>
-        <pc:spChg chg="mod">
-          <ac:chgData name="기일 권" userId="2ef98fef2c7306f1" providerId="LiveId" clId="{08ECA750-B2CA-48AB-A58D-3D63F452242C}" dt="2023-11-30T03:56:28.399" v="291" actId="122"/>
-          <ac:spMkLst>
-            <pc:docMk/>
-            <pc:sldMk cId="883637149" sldId="258"/>
-            <ac:spMk id="6" creationId="{6AD760A5-771A-9EC6-F300-2A18AF3EAD3B}"/>
-          </ac:spMkLst>
-        </pc:spChg>
-        <pc:spChg chg="mod">
-          <ac:chgData name="기일 권" userId="2ef98fef2c7306f1" providerId="LiveId" clId="{08ECA750-B2CA-48AB-A58D-3D63F452242C}" dt="2023-11-30T03:56:55.604" v="294" actId="122"/>
-          <ac:spMkLst>
-            <pc:docMk/>
-            <pc:sldMk cId="883637149" sldId="258"/>
-            <ac:spMk id="11" creationId="{A1391841-A2CC-7C1E-87EE-6AF3BCDBC383}"/>
-          </ac:spMkLst>
-        </pc:spChg>
-        <pc:spChg chg="mod">
-          <ac:chgData name="기일 권" userId="2ef98fef2c7306f1" providerId="LiveId" clId="{08ECA750-B2CA-48AB-A58D-3D63F452242C}" dt="2023-11-30T03:57:16.118" v="297" actId="1076"/>
-          <ac:spMkLst>
-            <pc:docMk/>
-            <pc:sldMk cId="883637149" sldId="258"/>
-            <ac:spMk id="13" creationId="{FD085E6C-122B-0091-1712-C27DC8AFDD15}"/>
-          </ac:spMkLst>
-        </pc:spChg>
-        <pc:spChg chg="mod">
-          <ac:chgData name="기일 권" userId="2ef98fef2c7306f1" providerId="LiveId" clId="{08ECA750-B2CA-48AB-A58D-3D63F452242C}" dt="2023-11-30T03:56:43.768" v="292" actId="255"/>
-          <ac:spMkLst>
-            <pc:docMk/>
-            <pc:sldMk cId="883637149" sldId="258"/>
-            <ac:spMk id="17" creationId="{168B88C8-5B87-C8D4-029A-B80B327AB195}"/>
-          </ac:spMkLst>
-        </pc:spChg>
-        <pc:spChg chg="mod">
-          <ac:chgData name="기일 권" userId="2ef98fef2c7306f1" providerId="LiveId" clId="{08ECA750-B2CA-48AB-A58D-3D63F452242C}" dt="2023-11-30T03:54:42.273" v="214" actId="14100"/>
-          <ac:spMkLst>
-            <pc:docMk/>
-            <pc:sldMk cId="883637149" sldId="258"/>
-            <ac:spMk id="21" creationId="{1915A791-CF96-C9C8-0706-A961E8D4EFC7}"/>
-          </ac:spMkLst>
-        </pc:spChg>
-      </pc:sldChg>
-      <pc:sldChg chg="modSp mod">
-        <pc:chgData name="기일 권" userId="2ef98fef2c7306f1" providerId="LiveId" clId="{08ECA750-B2CA-48AB-A58D-3D63F452242C}" dt="2023-11-30T03:57:48.605" v="303" actId="1076"/>
-        <pc:sldMkLst>
-          <pc:docMk/>
-          <pc:sldMk cId="3084318984" sldId="259"/>
-        </pc:sldMkLst>
-        <pc:spChg chg="mod">
-          <ac:chgData name="기일 권" userId="2ef98fef2c7306f1" providerId="LiveId" clId="{08ECA750-B2CA-48AB-A58D-3D63F452242C}" dt="2023-11-30T03:57:48.605" v="303" actId="1076"/>
-          <ac:spMkLst>
-            <pc:docMk/>
-            <pc:sldMk cId="3084318984" sldId="259"/>
-            <ac:spMk id="5" creationId="{90084524-CC88-D85E-32D8-6B06B0BA79D5}"/>
-          </ac:spMkLst>
-        </pc:spChg>
-        <pc:spChg chg="mod">
-          <ac:chgData name="기일 권" userId="2ef98fef2c7306f1" providerId="LiveId" clId="{08ECA750-B2CA-48AB-A58D-3D63F452242C}" dt="2023-11-30T03:57:39.349" v="301" actId="122"/>
-          <ac:spMkLst>
-            <pc:docMk/>
-            <pc:sldMk cId="3084318984" sldId="259"/>
-            <ac:spMk id="6" creationId="{6AD760A5-771A-9EC6-F300-2A18AF3EAD3B}"/>
-          </ac:spMkLst>
-        </pc:spChg>
-      </pc:sldChg>
-      <pc:sldChg chg="addSp delSp modSp mod">
-        <pc:chgData name="기일 권" userId="2ef98fef2c7306f1" providerId="LiveId" clId="{08ECA750-B2CA-48AB-A58D-3D63F452242C}" dt="2023-11-30T03:58:19.098" v="308" actId="207"/>
-        <pc:sldMkLst>
-          <pc:docMk/>
-          <pc:sldMk cId="29389827" sldId="260"/>
-        </pc:sldMkLst>
-        <pc:spChg chg="del">
-          <ac:chgData name="기일 권" userId="2ef98fef2c7306f1" providerId="LiveId" clId="{08ECA750-B2CA-48AB-A58D-3D63F452242C}" dt="2023-11-30T03:57:55.361" v="304" actId="478"/>
-          <ac:spMkLst>
-            <pc:docMk/>
-            <pc:sldMk cId="29389827" sldId="260"/>
-            <ac:spMk id="5" creationId="{90084524-CC88-D85E-32D8-6B06B0BA79D5}"/>
-          </ac:spMkLst>
-        </pc:spChg>
-        <pc:spChg chg="del">
-          <ac:chgData name="기일 권" userId="2ef98fef2c7306f1" providerId="LiveId" clId="{08ECA750-B2CA-48AB-A58D-3D63F452242C}" dt="2023-11-30T03:57:57.440" v="305" actId="478"/>
-          <ac:spMkLst>
-            <pc:docMk/>
-            <pc:sldMk cId="29389827" sldId="260"/>
-            <ac:spMk id="6" creationId="{6AD760A5-771A-9EC6-F300-2A18AF3EAD3B}"/>
-          </ac:spMkLst>
-        </pc:spChg>
-        <pc:spChg chg="add mod">
-          <ac:chgData name="기일 권" userId="2ef98fef2c7306f1" providerId="LiveId" clId="{08ECA750-B2CA-48AB-A58D-3D63F452242C}" dt="2023-11-30T03:57:57.653" v="306"/>
-          <ac:spMkLst>
-            <pc:docMk/>
-            <pc:sldMk cId="29389827" sldId="260"/>
-            <ac:spMk id="7" creationId="{BDD01290-90CC-838E-5535-EBF7F717E033}"/>
-          </ac:spMkLst>
-        </pc:spChg>
-        <pc:spChg chg="mod">
-          <ac:chgData name="기일 권" userId="2ef98fef2c7306f1" providerId="LiveId" clId="{08ECA750-B2CA-48AB-A58D-3D63F452242C}" dt="2023-11-30T03:58:19.098" v="308" actId="207"/>
-          <ac:spMkLst>
-            <pc:docMk/>
-            <pc:sldMk cId="29389827" sldId="260"/>
-            <ac:spMk id="12" creationId="{DBF260B7-324A-A20A-5AA9-9885DC0410BD}"/>
-          </ac:spMkLst>
-        </pc:spChg>
-        <pc:spChg chg="add mod">
-          <ac:chgData name="기일 권" userId="2ef98fef2c7306f1" providerId="LiveId" clId="{08ECA750-B2CA-48AB-A58D-3D63F452242C}" dt="2023-11-30T03:57:57.653" v="306"/>
-          <ac:spMkLst>
-            <pc:docMk/>
-            <pc:sldMk cId="29389827" sldId="260"/>
-            <ac:spMk id="13" creationId="{B5B26E9E-837D-059A-8A07-B8FCB3F568FF}"/>
-          </ac:spMkLst>
-        </pc:spChg>
-      </pc:sldChg>
-      <pc:sldChg chg="addSp delSp modSp mod">
-        <pc:chgData name="기일 권" userId="2ef98fef2c7306f1" providerId="LiveId" clId="{08ECA750-B2CA-48AB-A58D-3D63F452242C}" dt="2023-11-30T03:58:39.754" v="311"/>
-        <pc:sldMkLst>
-          <pc:docMk/>
-          <pc:sldMk cId="691644609" sldId="261"/>
-        </pc:sldMkLst>
-        <pc:spChg chg="add mod">
-          <ac:chgData name="기일 권" userId="2ef98fef2c7306f1" providerId="LiveId" clId="{08ECA750-B2CA-48AB-A58D-3D63F452242C}" dt="2023-11-30T03:58:39.754" v="311"/>
-          <ac:spMkLst>
-            <pc:docMk/>
-            <pc:sldMk cId="691644609" sldId="261"/>
-            <ac:spMk id="2" creationId="{FCD0A4C0-9296-7C32-9F12-FDBF1EDC09A0}"/>
-          </ac:spMkLst>
-        </pc:spChg>
-        <pc:spChg chg="add mod">
-          <ac:chgData name="기일 권" userId="2ef98fef2c7306f1" providerId="LiveId" clId="{08ECA750-B2CA-48AB-A58D-3D63F452242C}" dt="2023-11-30T03:58:39.754" v="311"/>
-          <ac:spMkLst>
-            <pc:docMk/>
-            <pc:sldMk cId="691644609" sldId="261"/>
-            <ac:spMk id="3" creationId="{9CF9D4A3-D8E1-6F51-0F8F-0C69AF5C431D}"/>
-          </ac:spMkLst>
-        </pc:spChg>
-        <pc:spChg chg="del">
-          <ac:chgData name="기일 권" userId="2ef98fef2c7306f1" providerId="LiveId" clId="{08ECA750-B2CA-48AB-A58D-3D63F452242C}" dt="2023-11-30T03:58:31.688" v="309" actId="478"/>
-          <ac:spMkLst>
-            <pc:docMk/>
-            <pc:sldMk cId="691644609" sldId="261"/>
-            <ac:spMk id="5" creationId="{90084524-CC88-D85E-32D8-6B06B0BA79D5}"/>
-          </ac:spMkLst>
-        </pc:spChg>
-        <pc:spChg chg="del">
-          <ac:chgData name="기일 권" userId="2ef98fef2c7306f1" providerId="LiveId" clId="{08ECA750-B2CA-48AB-A58D-3D63F452242C}" dt="2023-11-30T03:58:32.569" v="310" actId="478"/>
-          <ac:spMkLst>
-            <pc:docMk/>
-            <pc:sldMk cId="691644609" sldId="261"/>
-            <ac:spMk id="6" creationId="{6AD760A5-771A-9EC6-F300-2A18AF3EAD3B}"/>
-          </ac:spMkLst>
-        </pc:spChg>
-      </pc:sldChg>
-      <pc:sldChg chg="addSp delSp modSp mod">
-        <pc:chgData name="기일 권" userId="2ef98fef2c7306f1" providerId="LiveId" clId="{08ECA750-B2CA-48AB-A58D-3D63F452242C}" dt="2023-11-30T04:00:13.988" v="315"/>
-        <pc:sldMkLst>
-          <pc:docMk/>
-          <pc:sldMk cId="1885541940" sldId="262"/>
-        </pc:sldMkLst>
-        <pc:spChg chg="add mod">
-          <ac:chgData name="기일 권" userId="2ef98fef2c7306f1" providerId="LiveId" clId="{08ECA750-B2CA-48AB-A58D-3D63F452242C}" dt="2023-11-30T04:00:13.988" v="315"/>
-          <ac:spMkLst>
-            <pc:docMk/>
-            <pc:sldMk cId="1885541940" sldId="262"/>
-            <ac:spMk id="3" creationId="{52DD17C5-CFC4-CE55-88CF-83539D343534}"/>
-          </ac:spMkLst>
-        </pc:spChg>
-        <pc:spChg chg="add mod">
-          <ac:chgData name="기일 권" userId="2ef98fef2c7306f1" providerId="LiveId" clId="{08ECA750-B2CA-48AB-A58D-3D63F452242C}" dt="2023-11-30T04:00:13.988" v="315"/>
-          <ac:spMkLst>
-            <pc:docMk/>
-            <pc:sldMk cId="1885541940" sldId="262"/>
-            <ac:spMk id="4" creationId="{D6498CFB-8998-3727-E95B-384EF57F613B}"/>
-          </ac:spMkLst>
-        </pc:spChg>
-        <pc:spChg chg="del">
-          <ac:chgData name="기일 권" userId="2ef98fef2c7306f1" providerId="LiveId" clId="{08ECA750-B2CA-48AB-A58D-3D63F452242C}" dt="2023-11-30T04:00:09.033" v="313" actId="478"/>
-          <ac:spMkLst>
-            <pc:docMk/>
-            <pc:sldMk cId="1885541940" sldId="262"/>
-            <ac:spMk id="5" creationId="{90084524-CC88-D85E-32D8-6B06B0BA79D5}"/>
-          </ac:spMkLst>
-        </pc:spChg>
-        <pc:spChg chg="del">
-          <ac:chgData name="기일 권" userId="2ef98fef2c7306f1" providerId="LiveId" clId="{08ECA750-B2CA-48AB-A58D-3D63F452242C}" dt="2023-11-30T04:00:10.066" v="314" actId="478"/>
-          <ac:spMkLst>
-            <pc:docMk/>
-            <pc:sldMk cId="1885541940" sldId="262"/>
-            <ac:spMk id="6" creationId="{6AD760A5-771A-9EC6-F300-2A18AF3EAD3B}"/>
-          </ac:spMkLst>
-        </pc:spChg>
-      </pc:sldChg>
-      <pc:sldChg chg="addSp delSp modSp mod">
-        <pc:chgData name="기일 권" userId="2ef98fef2c7306f1" providerId="LiveId" clId="{08ECA750-B2CA-48AB-A58D-3D63F452242C}" dt="2023-11-30T04:00:31.099" v="318"/>
-        <pc:sldMkLst>
-          <pc:docMk/>
-          <pc:sldMk cId="957528637" sldId="263"/>
-        </pc:sldMkLst>
-        <pc:spChg chg="add mod">
-          <ac:chgData name="기일 권" userId="2ef98fef2c7306f1" providerId="LiveId" clId="{08ECA750-B2CA-48AB-A58D-3D63F452242C}" dt="2023-11-30T04:00:31.099" v="318"/>
-          <ac:spMkLst>
-            <pc:docMk/>
-            <pc:sldMk cId="957528637" sldId="263"/>
-            <ac:spMk id="2" creationId="{1E96FCE7-E40E-C3B1-08FE-C83578ACFB27}"/>
-          </ac:spMkLst>
-        </pc:spChg>
-        <pc:spChg chg="add mod">
-          <ac:chgData name="기일 권" userId="2ef98fef2c7306f1" providerId="LiveId" clId="{08ECA750-B2CA-48AB-A58D-3D63F452242C}" dt="2023-11-30T04:00:31.099" v="318"/>
-          <ac:spMkLst>
-            <pc:docMk/>
-            <pc:sldMk cId="957528637" sldId="263"/>
-            <ac:spMk id="3" creationId="{2C37CE74-31EA-5F67-AC37-8845F4ACEE43}"/>
-          </ac:spMkLst>
-        </pc:spChg>
-        <pc:spChg chg="del">
-          <ac:chgData name="기일 권" userId="2ef98fef2c7306f1" providerId="LiveId" clId="{08ECA750-B2CA-48AB-A58D-3D63F452242C}" dt="2023-11-30T04:00:25.927" v="316" actId="478"/>
-          <ac:spMkLst>
-            <pc:docMk/>
-            <pc:sldMk cId="957528637" sldId="263"/>
-            <ac:spMk id="5" creationId="{90084524-CC88-D85E-32D8-6B06B0BA79D5}"/>
-          </ac:spMkLst>
-        </pc:spChg>
-        <pc:spChg chg="del">
-          <ac:chgData name="기일 권" userId="2ef98fef2c7306f1" providerId="LiveId" clId="{08ECA750-B2CA-48AB-A58D-3D63F452242C}" dt="2023-11-30T04:00:26.771" v="317" actId="478"/>
-          <ac:spMkLst>
-            <pc:docMk/>
-            <pc:sldMk cId="957528637" sldId="263"/>
-            <ac:spMk id="6" creationId="{6AD760A5-771A-9EC6-F300-2A18AF3EAD3B}"/>
-          </ac:spMkLst>
-        </pc:spChg>
-      </pc:sldChg>
-      <pc:sldChg chg="modSp add mod">
-        <pc:chgData name="기일 권" userId="2ef98fef2c7306f1" providerId="LiveId" clId="{08ECA750-B2CA-48AB-A58D-3D63F452242C}" dt="2023-11-30T03:55:26.070" v="282" actId="27636"/>
-        <pc:sldMkLst>
-          <pc:docMk/>
-          <pc:sldMk cId="3085192147" sldId="274"/>
-        </pc:sldMkLst>
-        <pc:spChg chg="mod">
-          <ac:chgData name="기일 권" userId="2ef98fef2c7306f1" providerId="LiveId" clId="{08ECA750-B2CA-48AB-A58D-3D63F452242C}" dt="2023-11-30T03:55:26.070" v="282" actId="27636"/>
-          <ac:spMkLst>
-            <pc:docMk/>
-            <pc:sldMk cId="3085192147" sldId="274"/>
-            <ac:spMk id="5" creationId="{90084524-CC88-D85E-32D8-6B06B0BA79D5}"/>
-          </ac:spMkLst>
-        </pc:spChg>
-      </pc:sldChg>
-    </pc:docChg>
-  </pc:docChgLst>
-  <pc:docChgLst>
     <pc:chgData name="기일 권" userId="2ef98fef2c7306f1" providerId="LiveId" clId="{419890C3-D57B-4747-8E43-33395A2773E5}"/>
     <pc:docChg chg="undo custSel addSld modSld sldOrd">
       <pc:chgData name="기일 권" userId="2ef98fef2c7306f1" providerId="LiveId" clId="{419890C3-D57B-4747-8E43-33395A2773E5}" dt="2023-12-20T08:38:38.066" v="10951" actId="113"/>
@@ -3618,6 +3282,342 @@
       </pc:sldChg>
     </pc:docChg>
   </pc:docChgLst>
+  <pc:docChgLst>
+    <pc:chgData name="기일 권" userId="2ef98fef2c7306f1" providerId="LiveId" clId="{08ECA750-B2CA-48AB-A58D-3D63F452242C}"/>
+    <pc:docChg chg="undo custSel addSld modSld">
+      <pc:chgData name="기일 권" userId="2ef98fef2c7306f1" providerId="LiveId" clId="{08ECA750-B2CA-48AB-A58D-3D63F452242C}" dt="2023-11-30T04:00:31.099" v="318"/>
+      <pc:docMkLst>
+        <pc:docMk/>
+      </pc:docMkLst>
+      <pc:sldChg chg="modSp mod">
+        <pc:chgData name="기일 권" userId="2ef98fef2c7306f1" providerId="LiveId" clId="{08ECA750-B2CA-48AB-A58D-3D63F452242C}" dt="2023-11-30T03:55:51.905" v="285" actId="122"/>
+        <pc:sldMkLst>
+          <pc:docMk/>
+          <pc:sldMk cId="3569210928" sldId="256"/>
+        </pc:sldMkLst>
+        <pc:spChg chg="mod">
+          <ac:chgData name="기일 권" userId="2ef98fef2c7306f1" providerId="LiveId" clId="{08ECA750-B2CA-48AB-A58D-3D63F452242C}" dt="2023-11-30T03:55:40.568" v="283" actId="255"/>
+          <ac:spMkLst>
+            <pc:docMk/>
+            <pc:sldMk cId="3569210928" sldId="256"/>
+            <ac:spMk id="2" creationId="{00000000-0000-0000-0000-000000000000}"/>
+          </ac:spMkLst>
+        </pc:spChg>
+        <pc:spChg chg="mod">
+          <ac:chgData name="기일 권" userId="2ef98fef2c7306f1" providerId="LiveId" clId="{08ECA750-B2CA-48AB-A58D-3D63F452242C}" dt="2023-11-30T03:55:51.905" v="285" actId="122"/>
+          <ac:spMkLst>
+            <pc:docMk/>
+            <pc:sldMk cId="3569210928" sldId="256"/>
+            <ac:spMk id="6" creationId="{C967072B-F25C-AC0D-F3A6-8FE1166ACA47}"/>
+          </ac:spMkLst>
+        </pc:spChg>
+      </pc:sldChg>
+      <pc:sldChg chg="modSp mod">
+        <pc:chgData name="기일 권" userId="2ef98fef2c7306f1" providerId="LiveId" clId="{08ECA750-B2CA-48AB-A58D-3D63F452242C}" dt="2023-11-30T03:56:10.509" v="288" actId="122"/>
+        <pc:sldMkLst>
+          <pc:docMk/>
+          <pc:sldMk cId="99140326" sldId="257"/>
+        </pc:sldMkLst>
+        <pc:spChg chg="mod">
+          <ac:chgData name="기일 권" userId="2ef98fef2c7306f1" providerId="LiveId" clId="{08ECA750-B2CA-48AB-A58D-3D63F452242C}" dt="2023-11-30T03:56:00.074" v="286" actId="255"/>
+          <ac:spMkLst>
+            <pc:docMk/>
+            <pc:sldMk cId="99140326" sldId="257"/>
+            <ac:spMk id="5" creationId="{90084524-CC88-D85E-32D8-6B06B0BA79D5}"/>
+          </ac:spMkLst>
+        </pc:spChg>
+        <pc:spChg chg="mod">
+          <ac:chgData name="기일 권" userId="2ef98fef2c7306f1" providerId="LiveId" clId="{08ECA750-B2CA-48AB-A58D-3D63F452242C}" dt="2023-11-30T03:56:10.509" v="288" actId="122"/>
+          <ac:spMkLst>
+            <pc:docMk/>
+            <pc:sldMk cId="99140326" sldId="257"/>
+            <ac:spMk id="6" creationId="{6AD760A5-771A-9EC6-F300-2A18AF3EAD3B}"/>
+          </ac:spMkLst>
+        </pc:spChg>
+        <pc:graphicFrameChg chg="mod modGraphic">
+          <ac:chgData name="기일 권" userId="2ef98fef2c7306f1" providerId="LiveId" clId="{08ECA750-B2CA-48AB-A58D-3D63F452242C}" dt="2023-11-30T03:54:58.196" v="216" actId="20577"/>
+          <ac:graphicFrameMkLst>
+            <pc:docMk/>
+            <pc:sldMk cId="99140326" sldId="257"/>
+            <ac:graphicFrameMk id="12" creationId="{69D47D66-BDAC-B7B6-9634-FDE8CE74C23B}"/>
+          </ac:graphicFrameMkLst>
+        </pc:graphicFrameChg>
+      </pc:sldChg>
+      <pc:sldChg chg="modSp mod">
+        <pc:chgData name="기일 권" userId="2ef98fef2c7306f1" providerId="LiveId" clId="{08ECA750-B2CA-48AB-A58D-3D63F452242C}" dt="2023-11-30T03:59:44.851" v="312" actId="207"/>
+        <pc:sldMkLst>
+          <pc:docMk/>
+          <pc:sldMk cId="883637149" sldId="258"/>
+        </pc:sldMkLst>
+        <pc:spChg chg="mod">
+          <ac:chgData name="기일 권" userId="2ef98fef2c7306f1" providerId="LiveId" clId="{08ECA750-B2CA-48AB-A58D-3D63F452242C}" dt="2023-11-30T03:59:44.851" v="312" actId="207"/>
+          <ac:spMkLst>
+            <pc:docMk/>
+            <pc:sldMk cId="883637149" sldId="258"/>
+            <ac:spMk id="3" creationId="{B8E5EDF5-1D07-0FF7-846E-CC438A46C07D}"/>
+          </ac:spMkLst>
+        </pc:spChg>
+        <pc:spChg chg="mod">
+          <ac:chgData name="기일 권" userId="2ef98fef2c7306f1" providerId="LiveId" clId="{08ECA750-B2CA-48AB-A58D-3D63F452242C}" dt="2023-11-30T03:59:44.851" v="312" actId="207"/>
+          <ac:spMkLst>
+            <pc:docMk/>
+            <pc:sldMk cId="883637149" sldId="258"/>
+            <ac:spMk id="4" creationId="{9A86D59B-7DE3-4AC3-BFE0-CF56B118FB3A}"/>
+          </ac:spMkLst>
+        </pc:spChg>
+        <pc:spChg chg="mod">
+          <ac:chgData name="기일 권" userId="2ef98fef2c7306f1" providerId="LiveId" clId="{08ECA750-B2CA-48AB-A58D-3D63F452242C}" dt="2023-11-30T03:56:22.986" v="289" actId="255"/>
+          <ac:spMkLst>
+            <pc:docMk/>
+            <pc:sldMk cId="883637149" sldId="258"/>
+            <ac:spMk id="5" creationId="{90084524-CC88-D85E-32D8-6B06B0BA79D5}"/>
+          </ac:spMkLst>
+        </pc:spChg>
+        <pc:spChg chg="mod">
+          <ac:chgData name="기일 권" userId="2ef98fef2c7306f1" providerId="LiveId" clId="{08ECA750-B2CA-48AB-A58D-3D63F452242C}" dt="2023-11-30T03:56:28.399" v="291" actId="122"/>
+          <ac:spMkLst>
+            <pc:docMk/>
+            <pc:sldMk cId="883637149" sldId="258"/>
+            <ac:spMk id="6" creationId="{6AD760A5-771A-9EC6-F300-2A18AF3EAD3B}"/>
+          </ac:spMkLst>
+        </pc:spChg>
+        <pc:spChg chg="mod">
+          <ac:chgData name="기일 권" userId="2ef98fef2c7306f1" providerId="LiveId" clId="{08ECA750-B2CA-48AB-A58D-3D63F452242C}" dt="2023-11-30T03:56:55.604" v="294" actId="122"/>
+          <ac:spMkLst>
+            <pc:docMk/>
+            <pc:sldMk cId="883637149" sldId="258"/>
+            <ac:spMk id="11" creationId="{A1391841-A2CC-7C1E-87EE-6AF3BCDBC383}"/>
+          </ac:spMkLst>
+        </pc:spChg>
+        <pc:spChg chg="mod">
+          <ac:chgData name="기일 권" userId="2ef98fef2c7306f1" providerId="LiveId" clId="{08ECA750-B2CA-48AB-A58D-3D63F452242C}" dt="2023-11-30T03:57:16.118" v="297" actId="1076"/>
+          <ac:spMkLst>
+            <pc:docMk/>
+            <pc:sldMk cId="883637149" sldId="258"/>
+            <ac:spMk id="13" creationId="{FD085E6C-122B-0091-1712-C27DC8AFDD15}"/>
+          </ac:spMkLst>
+        </pc:spChg>
+        <pc:spChg chg="mod">
+          <ac:chgData name="기일 권" userId="2ef98fef2c7306f1" providerId="LiveId" clId="{08ECA750-B2CA-48AB-A58D-3D63F452242C}" dt="2023-11-30T03:56:43.768" v="292" actId="255"/>
+          <ac:spMkLst>
+            <pc:docMk/>
+            <pc:sldMk cId="883637149" sldId="258"/>
+            <ac:spMk id="17" creationId="{168B88C8-5B87-C8D4-029A-B80B327AB195}"/>
+          </ac:spMkLst>
+        </pc:spChg>
+        <pc:spChg chg="mod">
+          <ac:chgData name="기일 권" userId="2ef98fef2c7306f1" providerId="LiveId" clId="{08ECA750-B2CA-48AB-A58D-3D63F452242C}" dt="2023-11-30T03:54:42.273" v="214" actId="14100"/>
+          <ac:spMkLst>
+            <pc:docMk/>
+            <pc:sldMk cId="883637149" sldId="258"/>
+            <ac:spMk id="21" creationId="{1915A791-CF96-C9C8-0706-A961E8D4EFC7}"/>
+          </ac:spMkLst>
+        </pc:spChg>
+      </pc:sldChg>
+      <pc:sldChg chg="modSp mod">
+        <pc:chgData name="기일 권" userId="2ef98fef2c7306f1" providerId="LiveId" clId="{08ECA750-B2CA-48AB-A58D-3D63F452242C}" dt="2023-11-30T03:57:48.605" v="303" actId="1076"/>
+        <pc:sldMkLst>
+          <pc:docMk/>
+          <pc:sldMk cId="3084318984" sldId="259"/>
+        </pc:sldMkLst>
+        <pc:spChg chg="mod">
+          <ac:chgData name="기일 권" userId="2ef98fef2c7306f1" providerId="LiveId" clId="{08ECA750-B2CA-48AB-A58D-3D63F452242C}" dt="2023-11-30T03:57:48.605" v="303" actId="1076"/>
+          <ac:spMkLst>
+            <pc:docMk/>
+            <pc:sldMk cId="3084318984" sldId="259"/>
+            <ac:spMk id="5" creationId="{90084524-CC88-D85E-32D8-6B06B0BA79D5}"/>
+          </ac:spMkLst>
+        </pc:spChg>
+        <pc:spChg chg="mod">
+          <ac:chgData name="기일 권" userId="2ef98fef2c7306f1" providerId="LiveId" clId="{08ECA750-B2CA-48AB-A58D-3D63F452242C}" dt="2023-11-30T03:57:39.349" v="301" actId="122"/>
+          <ac:spMkLst>
+            <pc:docMk/>
+            <pc:sldMk cId="3084318984" sldId="259"/>
+            <ac:spMk id="6" creationId="{6AD760A5-771A-9EC6-F300-2A18AF3EAD3B}"/>
+          </ac:spMkLst>
+        </pc:spChg>
+      </pc:sldChg>
+      <pc:sldChg chg="addSp delSp modSp mod">
+        <pc:chgData name="기일 권" userId="2ef98fef2c7306f1" providerId="LiveId" clId="{08ECA750-B2CA-48AB-A58D-3D63F452242C}" dt="2023-11-30T03:58:19.098" v="308" actId="207"/>
+        <pc:sldMkLst>
+          <pc:docMk/>
+          <pc:sldMk cId="29389827" sldId="260"/>
+        </pc:sldMkLst>
+        <pc:spChg chg="del">
+          <ac:chgData name="기일 권" userId="2ef98fef2c7306f1" providerId="LiveId" clId="{08ECA750-B2CA-48AB-A58D-3D63F452242C}" dt="2023-11-30T03:57:55.361" v="304" actId="478"/>
+          <ac:spMkLst>
+            <pc:docMk/>
+            <pc:sldMk cId="29389827" sldId="260"/>
+            <ac:spMk id="5" creationId="{90084524-CC88-D85E-32D8-6B06B0BA79D5}"/>
+          </ac:spMkLst>
+        </pc:spChg>
+        <pc:spChg chg="del">
+          <ac:chgData name="기일 권" userId="2ef98fef2c7306f1" providerId="LiveId" clId="{08ECA750-B2CA-48AB-A58D-3D63F452242C}" dt="2023-11-30T03:57:57.440" v="305" actId="478"/>
+          <ac:spMkLst>
+            <pc:docMk/>
+            <pc:sldMk cId="29389827" sldId="260"/>
+            <ac:spMk id="6" creationId="{6AD760A5-771A-9EC6-F300-2A18AF3EAD3B}"/>
+          </ac:spMkLst>
+        </pc:spChg>
+        <pc:spChg chg="add mod">
+          <ac:chgData name="기일 권" userId="2ef98fef2c7306f1" providerId="LiveId" clId="{08ECA750-B2CA-48AB-A58D-3D63F452242C}" dt="2023-11-30T03:57:57.653" v="306"/>
+          <ac:spMkLst>
+            <pc:docMk/>
+            <pc:sldMk cId="29389827" sldId="260"/>
+            <ac:spMk id="7" creationId="{BDD01290-90CC-838E-5535-EBF7F717E033}"/>
+          </ac:spMkLst>
+        </pc:spChg>
+        <pc:spChg chg="mod">
+          <ac:chgData name="기일 권" userId="2ef98fef2c7306f1" providerId="LiveId" clId="{08ECA750-B2CA-48AB-A58D-3D63F452242C}" dt="2023-11-30T03:58:19.098" v="308" actId="207"/>
+          <ac:spMkLst>
+            <pc:docMk/>
+            <pc:sldMk cId="29389827" sldId="260"/>
+            <ac:spMk id="12" creationId="{DBF260B7-324A-A20A-5AA9-9885DC0410BD}"/>
+          </ac:spMkLst>
+        </pc:spChg>
+        <pc:spChg chg="add mod">
+          <ac:chgData name="기일 권" userId="2ef98fef2c7306f1" providerId="LiveId" clId="{08ECA750-B2CA-48AB-A58D-3D63F452242C}" dt="2023-11-30T03:57:57.653" v="306"/>
+          <ac:spMkLst>
+            <pc:docMk/>
+            <pc:sldMk cId="29389827" sldId="260"/>
+            <ac:spMk id="13" creationId="{B5B26E9E-837D-059A-8A07-B8FCB3F568FF}"/>
+          </ac:spMkLst>
+        </pc:spChg>
+      </pc:sldChg>
+      <pc:sldChg chg="addSp delSp modSp mod">
+        <pc:chgData name="기일 권" userId="2ef98fef2c7306f1" providerId="LiveId" clId="{08ECA750-B2CA-48AB-A58D-3D63F452242C}" dt="2023-11-30T03:58:39.754" v="311"/>
+        <pc:sldMkLst>
+          <pc:docMk/>
+          <pc:sldMk cId="691644609" sldId="261"/>
+        </pc:sldMkLst>
+        <pc:spChg chg="add mod">
+          <ac:chgData name="기일 권" userId="2ef98fef2c7306f1" providerId="LiveId" clId="{08ECA750-B2CA-48AB-A58D-3D63F452242C}" dt="2023-11-30T03:58:39.754" v="311"/>
+          <ac:spMkLst>
+            <pc:docMk/>
+            <pc:sldMk cId="691644609" sldId="261"/>
+            <ac:spMk id="2" creationId="{FCD0A4C0-9296-7C32-9F12-FDBF1EDC09A0}"/>
+          </ac:spMkLst>
+        </pc:spChg>
+        <pc:spChg chg="add mod">
+          <ac:chgData name="기일 권" userId="2ef98fef2c7306f1" providerId="LiveId" clId="{08ECA750-B2CA-48AB-A58D-3D63F452242C}" dt="2023-11-30T03:58:39.754" v="311"/>
+          <ac:spMkLst>
+            <pc:docMk/>
+            <pc:sldMk cId="691644609" sldId="261"/>
+            <ac:spMk id="3" creationId="{9CF9D4A3-D8E1-6F51-0F8F-0C69AF5C431D}"/>
+          </ac:spMkLst>
+        </pc:spChg>
+        <pc:spChg chg="del">
+          <ac:chgData name="기일 권" userId="2ef98fef2c7306f1" providerId="LiveId" clId="{08ECA750-B2CA-48AB-A58D-3D63F452242C}" dt="2023-11-30T03:58:31.688" v="309" actId="478"/>
+          <ac:spMkLst>
+            <pc:docMk/>
+            <pc:sldMk cId="691644609" sldId="261"/>
+            <ac:spMk id="5" creationId="{90084524-CC88-D85E-32D8-6B06B0BA79D5}"/>
+          </ac:spMkLst>
+        </pc:spChg>
+        <pc:spChg chg="del">
+          <ac:chgData name="기일 권" userId="2ef98fef2c7306f1" providerId="LiveId" clId="{08ECA750-B2CA-48AB-A58D-3D63F452242C}" dt="2023-11-30T03:58:32.569" v="310" actId="478"/>
+          <ac:spMkLst>
+            <pc:docMk/>
+            <pc:sldMk cId="691644609" sldId="261"/>
+            <ac:spMk id="6" creationId="{6AD760A5-771A-9EC6-F300-2A18AF3EAD3B}"/>
+          </ac:spMkLst>
+        </pc:spChg>
+      </pc:sldChg>
+      <pc:sldChg chg="addSp delSp modSp mod">
+        <pc:chgData name="기일 권" userId="2ef98fef2c7306f1" providerId="LiveId" clId="{08ECA750-B2CA-48AB-A58D-3D63F452242C}" dt="2023-11-30T04:00:13.988" v="315"/>
+        <pc:sldMkLst>
+          <pc:docMk/>
+          <pc:sldMk cId="1885541940" sldId="262"/>
+        </pc:sldMkLst>
+        <pc:spChg chg="add mod">
+          <ac:chgData name="기일 권" userId="2ef98fef2c7306f1" providerId="LiveId" clId="{08ECA750-B2CA-48AB-A58D-3D63F452242C}" dt="2023-11-30T04:00:13.988" v="315"/>
+          <ac:spMkLst>
+            <pc:docMk/>
+            <pc:sldMk cId="1885541940" sldId="262"/>
+            <ac:spMk id="3" creationId="{52DD17C5-CFC4-CE55-88CF-83539D343534}"/>
+          </ac:spMkLst>
+        </pc:spChg>
+        <pc:spChg chg="add mod">
+          <ac:chgData name="기일 권" userId="2ef98fef2c7306f1" providerId="LiveId" clId="{08ECA750-B2CA-48AB-A58D-3D63F452242C}" dt="2023-11-30T04:00:13.988" v="315"/>
+          <ac:spMkLst>
+            <pc:docMk/>
+            <pc:sldMk cId="1885541940" sldId="262"/>
+            <ac:spMk id="4" creationId="{D6498CFB-8998-3727-E95B-384EF57F613B}"/>
+          </ac:spMkLst>
+        </pc:spChg>
+        <pc:spChg chg="del">
+          <ac:chgData name="기일 권" userId="2ef98fef2c7306f1" providerId="LiveId" clId="{08ECA750-B2CA-48AB-A58D-3D63F452242C}" dt="2023-11-30T04:00:09.033" v="313" actId="478"/>
+          <ac:spMkLst>
+            <pc:docMk/>
+            <pc:sldMk cId="1885541940" sldId="262"/>
+            <ac:spMk id="5" creationId="{90084524-CC88-D85E-32D8-6B06B0BA79D5}"/>
+          </ac:spMkLst>
+        </pc:spChg>
+        <pc:spChg chg="del">
+          <ac:chgData name="기일 권" userId="2ef98fef2c7306f1" providerId="LiveId" clId="{08ECA750-B2CA-48AB-A58D-3D63F452242C}" dt="2023-11-30T04:00:10.066" v="314" actId="478"/>
+          <ac:spMkLst>
+            <pc:docMk/>
+            <pc:sldMk cId="1885541940" sldId="262"/>
+            <ac:spMk id="6" creationId="{6AD760A5-771A-9EC6-F300-2A18AF3EAD3B}"/>
+          </ac:spMkLst>
+        </pc:spChg>
+      </pc:sldChg>
+      <pc:sldChg chg="addSp delSp modSp mod">
+        <pc:chgData name="기일 권" userId="2ef98fef2c7306f1" providerId="LiveId" clId="{08ECA750-B2CA-48AB-A58D-3D63F452242C}" dt="2023-11-30T04:00:31.099" v="318"/>
+        <pc:sldMkLst>
+          <pc:docMk/>
+          <pc:sldMk cId="957528637" sldId="263"/>
+        </pc:sldMkLst>
+        <pc:spChg chg="add mod">
+          <ac:chgData name="기일 권" userId="2ef98fef2c7306f1" providerId="LiveId" clId="{08ECA750-B2CA-48AB-A58D-3D63F452242C}" dt="2023-11-30T04:00:31.099" v="318"/>
+          <ac:spMkLst>
+            <pc:docMk/>
+            <pc:sldMk cId="957528637" sldId="263"/>
+            <ac:spMk id="2" creationId="{1E96FCE7-E40E-C3B1-08FE-C83578ACFB27}"/>
+          </ac:spMkLst>
+        </pc:spChg>
+        <pc:spChg chg="add mod">
+          <ac:chgData name="기일 권" userId="2ef98fef2c7306f1" providerId="LiveId" clId="{08ECA750-B2CA-48AB-A58D-3D63F452242C}" dt="2023-11-30T04:00:31.099" v="318"/>
+          <ac:spMkLst>
+            <pc:docMk/>
+            <pc:sldMk cId="957528637" sldId="263"/>
+            <ac:spMk id="3" creationId="{2C37CE74-31EA-5F67-AC37-8845F4ACEE43}"/>
+          </ac:spMkLst>
+        </pc:spChg>
+        <pc:spChg chg="del">
+          <ac:chgData name="기일 권" userId="2ef98fef2c7306f1" providerId="LiveId" clId="{08ECA750-B2CA-48AB-A58D-3D63F452242C}" dt="2023-11-30T04:00:25.927" v="316" actId="478"/>
+          <ac:spMkLst>
+            <pc:docMk/>
+            <pc:sldMk cId="957528637" sldId="263"/>
+            <ac:spMk id="5" creationId="{90084524-CC88-D85E-32D8-6B06B0BA79D5}"/>
+          </ac:spMkLst>
+        </pc:spChg>
+        <pc:spChg chg="del">
+          <ac:chgData name="기일 권" userId="2ef98fef2c7306f1" providerId="LiveId" clId="{08ECA750-B2CA-48AB-A58D-3D63F452242C}" dt="2023-11-30T04:00:26.771" v="317" actId="478"/>
+          <ac:spMkLst>
+            <pc:docMk/>
+            <pc:sldMk cId="957528637" sldId="263"/>
+            <ac:spMk id="6" creationId="{6AD760A5-771A-9EC6-F300-2A18AF3EAD3B}"/>
+          </ac:spMkLst>
+        </pc:spChg>
+      </pc:sldChg>
+      <pc:sldChg chg="modSp add mod">
+        <pc:chgData name="기일 권" userId="2ef98fef2c7306f1" providerId="LiveId" clId="{08ECA750-B2CA-48AB-A58D-3D63F452242C}" dt="2023-11-30T03:55:26.070" v="282" actId="27636"/>
+        <pc:sldMkLst>
+          <pc:docMk/>
+          <pc:sldMk cId="3085192147" sldId="274"/>
+        </pc:sldMkLst>
+        <pc:spChg chg="mod">
+          <ac:chgData name="기일 권" userId="2ef98fef2c7306f1" providerId="LiveId" clId="{08ECA750-B2CA-48AB-A58D-3D63F452242C}" dt="2023-11-30T03:55:26.070" v="282" actId="27636"/>
+          <ac:spMkLst>
+            <pc:docMk/>
+            <pc:sldMk cId="3085192147" sldId="274"/>
+            <ac:spMk id="5" creationId="{90084524-CC88-D85E-32D8-6B06B0BA79D5}"/>
+          </ac:spMkLst>
+        </pc:spChg>
+      </pc:sldChg>
+    </pc:docChg>
+  </pc:docChgLst>
 </pc:chgInfo>
 </file>
 
@@ -3750,7 +3750,7 @@
           <a:p>
             <a:fld id="{2566825D-2B69-4989-8861-A6901ABADB6C}" type="datetimeFigureOut">
               <a:rPr lang="ko-KR" altLang="en-US" smtClean="0"/>
-              <a:t>2023-12-20</a:t>
+              <a:t>2024-01-02</a:t>
             </a:fld>
             <a:endParaRPr lang="ko-KR" altLang="en-US"/>
           </a:p>
@@ -3918,7 +3918,7 @@
           <a:p>
             <a:fld id="{2566825D-2B69-4989-8861-A6901ABADB6C}" type="datetimeFigureOut">
               <a:rPr lang="ko-KR" altLang="en-US" smtClean="0"/>
-              <a:t>2023-12-20</a:t>
+              <a:t>2024-01-02</a:t>
             </a:fld>
             <a:endParaRPr lang="ko-KR" altLang="en-US"/>
           </a:p>
@@ -4096,7 +4096,7 @@
           <a:p>
             <a:fld id="{2566825D-2B69-4989-8861-A6901ABADB6C}" type="datetimeFigureOut">
               <a:rPr lang="ko-KR" altLang="en-US" smtClean="0"/>
-              <a:t>2023-12-20</a:t>
+              <a:t>2024-01-02</a:t>
             </a:fld>
             <a:endParaRPr lang="ko-KR" altLang="en-US"/>
           </a:p>
@@ -4264,7 +4264,7 @@
           <a:p>
             <a:fld id="{2566825D-2B69-4989-8861-A6901ABADB6C}" type="datetimeFigureOut">
               <a:rPr lang="ko-KR" altLang="en-US" smtClean="0"/>
-              <a:t>2023-12-20</a:t>
+              <a:t>2024-01-02</a:t>
             </a:fld>
             <a:endParaRPr lang="ko-KR" altLang="en-US"/>
           </a:p>
@@ -4509,7 +4509,7 @@
           <a:p>
             <a:fld id="{2566825D-2B69-4989-8861-A6901ABADB6C}" type="datetimeFigureOut">
               <a:rPr lang="ko-KR" altLang="en-US" smtClean="0"/>
-              <a:t>2023-12-20</a:t>
+              <a:t>2024-01-02</a:t>
             </a:fld>
             <a:endParaRPr lang="ko-KR" altLang="en-US"/>
           </a:p>
@@ -4738,7 +4738,7 @@
           <a:p>
             <a:fld id="{2566825D-2B69-4989-8861-A6901ABADB6C}" type="datetimeFigureOut">
               <a:rPr lang="ko-KR" altLang="en-US" smtClean="0"/>
-              <a:t>2023-12-20</a:t>
+              <a:t>2024-01-02</a:t>
             </a:fld>
             <a:endParaRPr lang="ko-KR" altLang="en-US"/>
           </a:p>
@@ -5102,7 +5102,7 @@
           <a:p>
             <a:fld id="{2566825D-2B69-4989-8861-A6901ABADB6C}" type="datetimeFigureOut">
               <a:rPr lang="ko-KR" altLang="en-US" smtClean="0"/>
-              <a:t>2023-12-20</a:t>
+              <a:t>2024-01-02</a:t>
             </a:fld>
             <a:endParaRPr lang="ko-KR" altLang="en-US"/>
           </a:p>
@@ -5219,7 +5219,7 @@
           <a:p>
             <a:fld id="{2566825D-2B69-4989-8861-A6901ABADB6C}" type="datetimeFigureOut">
               <a:rPr lang="ko-KR" altLang="en-US" smtClean="0"/>
-              <a:t>2023-12-20</a:t>
+              <a:t>2024-01-02</a:t>
             </a:fld>
             <a:endParaRPr lang="ko-KR" altLang="en-US"/>
           </a:p>
@@ -5314,7 +5314,7 @@
           <a:p>
             <a:fld id="{2566825D-2B69-4989-8861-A6901ABADB6C}" type="datetimeFigureOut">
               <a:rPr lang="ko-KR" altLang="en-US" smtClean="0"/>
-              <a:t>2023-12-20</a:t>
+              <a:t>2024-01-02</a:t>
             </a:fld>
             <a:endParaRPr lang="ko-KR" altLang="en-US"/>
           </a:p>
@@ -5589,7 +5589,7 @@
           <a:p>
             <a:fld id="{2566825D-2B69-4989-8861-A6901ABADB6C}" type="datetimeFigureOut">
               <a:rPr lang="ko-KR" altLang="en-US" smtClean="0"/>
-              <a:t>2023-12-20</a:t>
+              <a:t>2024-01-02</a:t>
             </a:fld>
             <a:endParaRPr lang="ko-KR" altLang="en-US"/>
           </a:p>
@@ -5841,7 +5841,7 @@
           <a:p>
             <a:fld id="{2566825D-2B69-4989-8861-A6901ABADB6C}" type="datetimeFigureOut">
               <a:rPr lang="ko-KR" altLang="en-US" smtClean="0"/>
-              <a:t>2023-12-20</a:t>
+              <a:t>2024-01-02</a:t>
             </a:fld>
             <a:endParaRPr lang="ko-KR" altLang="en-US"/>
           </a:p>
@@ -6052,7 +6052,7 @@
           <a:p>
             <a:fld id="{2566825D-2B69-4989-8861-A6901ABADB6C}" type="datetimeFigureOut">
               <a:rPr lang="ko-KR" altLang="en-US" smtClean="0"/>
-              <a:t>2023-12-20</a:t>
+              <a:t>2024-01-02</a:t>
             </a:fld>
             <a:endParaRPr lang="ko-KR" altLang="en-US"/>
           </a:p>
@@ -7004,7 +7004,7 @@
               <a:buChar char="q"/>
             </a:pPr>
             <a:r>
-              <a:rPr lang="ko-KR" altLang="en-US" sz="1600" b="1" dirty="0">
+              <a:rPr lang="ko-KR" altLang="en-US" sz="1600" dirty="0">
                 <a:ea typeface="맑은 고딕"/>
               </a:rPr>
               <a:t>이슈 인지 및 대응에 걸리는 시간 대폭 감소 기대</a:t>
@@ -7131,7 +7131,7 @@
           <p:nvPr/>
         </p:nvPicPr>
         <p:blipFill>
-          <a:blip r:embed="rId2">
+          <a:blip r:embed="rId2" cstate="print">
             <a:extLst>
               <a:ext uri="{28A0092B-C50C-407E-A947-70E740481C1C}">
                 <a14:useLocalDpi xmlns:a14="http://schemas.microsoft.com/office/drawing/2010/main" val="0"/>
@@ -7167,7 +7167,7 @@
           <p:nvPr/>
         </p:nvPicPr>
         <p:blipFill>
-          <a:blip r:embed="rId3">
+          <a:blip r:embed="rId3" cstate="print">
             <a:extLst>
               <a:ext uri="{28A0092B-C50C-407E-A947-70E740481C1C}">
                 <a14:useLocalDpi xmlns:a14="http://schemas.microsoft.com/office/drawing/2010/main" val="0"/>
@@ -7368,7 +7368,7 @@
           <p:nvPr/>
         </p:nvPicPr>
         <p:blipFill>
-          <a:blip r:embed="rId3">
+          <a:blip r:embed="rId3" cstate="print">
             <a:extLst>
               <a:ext uri="{28A0092B-C50C-407E-A947-70E740481C1C}">
                 <a14:useLocalDpi xmlns:a14="http://schemas.microsoft.com/office/drawing/2010/main" val="0"/>
@@ -9171,37 +9171,37 @@
               <a:buChar char="q"/>
             </a:pPr>
             <a:r>
-              <a:rPr lang="en-US" altLang="ko-KR" sz="1600" b="1" dirty="0">
+              <a:rPr lang="en-US" altLang="ko-KR" sz="1600" dirty="0">
                 <a:ea typeface="맑은 고딕"/>
               </a:rPr>
               <a:t>Jira </a:t>
             </a:r>
             <a:r>
-              <a:rPr lang="ko-KR" altLang="en-US" sz="1600" b="1" dirty="0">
+              <a:rPr lang="ko-KR" altLang="en-US" sz="1600" dirty="0">
                 <a:ea typeface="맑은 고딕"/>
               </a:rPr>
               <a:t>내에서 </a:t>
             </a:r>
             <a:r>
-              <a:rPr lang="en-US" altLang="ko-KR" sz="1600" b="1" dirty="0">
+              <a:rPr lang="en-US" altLang="ko-KR" sz="1600" dirty="0">
                 <a:ea typeface="맑은 고딕"/>
               </a:rPr>
               <a:t>Automation </a:t>
             </a:r>
             <a:r>
-              <a:rPr lang="ko-KR" altLang="en-US" sz="1600" b="1" dirty="0">
+              <a:rPr lang="ko-KR" altLang="en-US" sz="1600" dirty="0">
                 <a:ea typeface="맑은 고딕"/>
               </a:rPr>
               <a:t>설정을 했을 때 담당자 명이 </a:t>
             </a:r>
             <a:r>
-              <a:rPr lang="ko-KR" altLang="en-US" sz="1600" b="1" dirty="0" err="1">
+              <a:rPr lang="ko-KR" altLang="en-US" sz="1600" dirty="0" err="1">
                 <a:ea typeface="맑은 고딕"/>
               </a:rPr>
               <a:t>탬플릿에</a:t>
             </a:r>
             <a:r>
-              <a:rPr lang="ko-KR" altLang="en-US" sz="1600" b="1" dirty="0">
+              <a:rPr lang="ko-KR" altLang="en-US" sz="1600" dirty="0">
                 <a:ea typeface="맑은 고딕"/>
               </a:rPr>
               <a:t> 입력되지 않은 상태로 생성되는 점 확인</a:t>
@@ -11856,7 +11856,7 @@
               <a:buChar char="q"/>
             </a:pPr>
             <a:r>
-              <a:rPr lang="ko-KR" altLang="en-US" sz="1600" b="1" dirty="0">
+              <a:rPr lang="ko-KR" altLang="en-US" sz="1600" dirty="0">
                 <a:ea typeface="맑은 고딕"/>
               </a:rPr>
               <a:t>커뮤니케이션 지연</a:t>
@@ -11998,7 +11998,7 @@
           <p:nvPr/>
         </p:nvPicPr>
         <p:blipFill>
-          <a:blip r:embed="rId2">
+          <a:blip r:embed="rId2" cstate="print">
             <a:extLst>
               <a:ext uri="{28A0092B-C50C-407E-A947-70E740481C1C}">
                 <a14:useLocalDpi xmlns:a14="http://schemas.microsoft.com/office/drawing/2010/main" val="0"/>
@@ -12088,7 +12088,7 @@
           <p:nvPr/>
         </p:nvPicPr>
         <p:blipFill>
-          <a:blip r:embed="rId3">
+          <a:blip r:embed="rId3" cstate="print">
             <a:extLst>
               <a:ext uri="{28A0092B-C50C-407E-A947-70E740481C1C}">
                 <a14:useLocalDpi xmlns:a14="http://schemas.microsoft.com/office/drawing/2010/main" val="0"/>
@@ -12510,7 +12510,7 @@
           <p:nvPr/>
         </p:nvPicPr>
         <p:blipFill>
-          <a:blip r:embed="rId3">
+          <a:blip r:embed="rId3" cstate="print">
             <a:extLst>
               <a:ext uri="{28A0092B-C50C-407E-A947-70E740481C1C}">
                 <a14:useLocalDpi xmlns:a14="http://schemas.microsoft.com/office/drawing/2010/main" val="0"/>
@@ -12809,7 +12809,7 @@
           <p:nvPr/>
         </p:nvPicPr>
         <p:blipFill>
-          <a:blip r:embed="rId2">
+          <a:blip r:embed="rId2" cstate="print">
             <a:extLst>
               <a:ext uri="{28A0092B-C50C-407E-A947-70E740481C1C}">
                 <a14:useLocalDpi xmlns:a14="http://schemas.microsoft.com/office/drawing/2010/main" val="0"/>
@@ -13388,19 +13388,19 @@
               <a:buChar char="q"/>
             </a:pPr>
             <a:r>
-              <a:rPr lang="ko-KR" altLang="en-US" sz="1600" b="1" dirty="0">
+              <a:rPr lang="ko-KR" altLang="en-US" sz="1600" dirty="0">
                 <a:ea typeface="맑은 고딕"/>
               </a:rPr>
               <a:t>사내 메신저가 </a:t>
             </a:r>
             <a:r>
-              <a:rPr lang="en-US" altLang="ko-KR" sz="1600" b="1" dirty="0">
+              <a:rPr lang="en-US" altLang="ko-KR" sz="1600" dirty="0">
                 <a:ea typeface="맑은 고딕"/>
               </a:rPr>
               <a:t>Jira web-hook </a:t>
             </a:r>
             <a:r>
-              <a:rPr lang="ko-KR" altLang="en-US" sz="1600" b="1" dirty="0">
+              <a:rPr lang="ko-KR" altLang="en-US" sz="1600" dirty="0">
                 <a:ea typeface="맑은 고딕"/>
               </a:rPr>
               <a:t>기능을 직접 지원하지 않음</a:t>
@@ -14167,7 +14167,7 @@
         <p:spPr>
           <a:xfrm>
             <a:off x="8362273" y="3934401"/>
-            <a:ext cx="3201789" cy="622543"/>
+            <a:ext cx="3201789" cy="437877"/>
           </a:xfrm>
           <a:prstGeom prst="rect">
             <a:avLst/>
@@ -14212,7 +14212,7 @@
               <a:rPr lang="ko-KR" altLang="en-US" sz="800" dirty="0">
                 <a:ea typeface="맑은 고딕"/>
               </a:rPr>
-              <a:t>외부 서비스 연동을 직접 할 수 있는 기능은 없음</a:t>
+              <a:t>외부 서비스 직접 연동 불가</a:t>
             </a:r>
             <a:endParaRPr lang="en-US" altLang="ko-KR" sz="800" dirty="0">
               <a:ea typeface="맑은 고딕"/>
@@ -14542,61 +14542,61 @@
               <a:buChar char="q"/>
             </a:pPr>
             <a:r>
-              <a:rPr lang="en-US" altLang="ko-KR" sz="1600" b="1" dirty="0">
+              <a:rPr lang="en-US" altLang="ko-KR" sz="1600" dirty="0">
                 <a:ea typeface="맑은 고딕"/>
               </a:rPr>
               <a:t>Synology chat </a:t>
             </a:r>
             <a:r>
-              <a:rPr lang="ko-KR" altLang="en-US" sz="1600" b="1" dirty="0">
+              <a:rPr lang="ko-KR" altLang="en-US" sz="1600" dirty="0">
                 <a:ea typeface="맑은 고딕"/>
               </a:rPr>
               <a:t>내 </a:t>
             </a:r>
             <a:r>
-              <a:rPr lang="en-US" altLang="ko-KR" sz="1600" b="1" dirty="0">
+              <a:rPr lang="en-US" altLang="ko-KR" sz="1600" dirty="0">
                 <a:ea typeface="맑은 고딕"/>
               </a:rPr>
               <a:t>chat bot </a:t>
             </a:r>
             <a:r>
-              <a:rPr lang="ko-KR" altLang="en-US" sz="1600" b="1" dirty="0">
+              <a:rPr lang="ko-KR" altLang="en-US" sz="1600" dirty="0">
                 <a:ea typeface="맑은 고딕"/>
               </a:rPr>
               <a:t>기능을 이용하여 </a:t>
             </a:r>
             <a:r>
-              <a:rPr lang="en-US" altLang="ko-KR" sz="1600" b="1" dirty="0">
+              <a:rPr lang="en-US" altLang="ko-KR" sz="1600" dirty="0">
                 <a:ea typeface="맑은 고딕"/>
               </a:rPr>
               <a:t>Jira </a:t>
             </a:r>
             <a:r>
-              <a:rPr lang="ko-KR" altLang="en-US" sz="1600" b="1" dirty="0">
+              <a:rPr lang="ko-KR" altLang="en-US" sz="1600" dirty="0">
                 <a:ea typeface="맑은 고딕"/>
               </a:rPr>
               <a:t>내 이벤트</a:t>
             </a:r>
             <a:r>
-              <a:rPr lang="en-US" altLang="ko-KR" sz="1600" b="1" dirty="0">
+              <a:rPr lang="en-US" altLang="ko-KR" sz="1600" dirty="0">
                 <a:ea typeface="맑은 고딕"/>
               </a:rPr>
               <a:t> </a:t>
             </a:r>
             <a:r>
-              <a:rPr lang="ko-KR" altLang="en-US" sz="1600" b="1" dirty="0">
+              <a:rPr lang="ko-KR" altLang="en-US" sz="1600" dirty="0">
                 <a:ea typeface="맑은 고딕"/>
               </a:rPr>
               <a:t>알림 </a:t>
             </a:r>
             <a:r>
-              <a:rPr lang="en-US" altLang="ko-KR" sz="1600" b="1" dirty="0">
+              <a:rPr lang="en-US" altLang="ko-KR" sz="1600" dirty="0">
                 <a:ea typeface="맑은 고딕"/>
               </a:rPr>
               <a:t>chat bot </a:t>
             </a:r>
             <a:r>
-              <a:rPr lang="ko-KR" altLang="en-US" sz="1600" b="1" dirty="0">
+              <a:rPr lang="ko-KR" altLang="en-US" sz="1600" dirty="0">
                 <a:ea typeface="맑은 고딕"/>
               </a:rPr>
               <a:t>구현</a:t>
@@ -15177,8 +15177,8 @@
         </p:nvSpPr>
         <p:spPr>
           <a:xfrm>
-            <a:off x="5035253" y="4227059"/>
-            <a:ext cx="1591675" cy="338554"/>
+            <a:off x="5032765" y="4227059"/>
+            <a:ext cx="1591675" cy="584775"/>
           </a:xfrm>
           <a:prstGeom prst="rect">
             <a:avLst/>
@@ -15213,6 +15213,21 @@
               </a:rPr>
               <a:t>서버</a:t>
             </a:r>
+            <a:endParaRPr lang="en-US" altLang="ko-KR" sz="1600" b="1" dirty="0">
+              <a:ea typeface="맑은 고딕"/>
+            </a:endParaRPr>
+          </a:p>
+          <a:p>
+            <a:pPr algn="ctr"/>
+            <a:r>
+              <a:rPr lang="en-US" altLang="ko-KR" sz="1600" b="1" dirty="0">
+                <a:ea typeface="맑은 고딕"/>
+              </a:rPr>
+              <a:t>Chat bot</a:t>
+            </a:r>
+            <a:endParaRPr lang="ko-KR" altLang="en-US" sz="1600" b="1" dirty="0">
+              <a:ea typeface="맑은 고딕"/>
+            </a:endParaRPr>
           </a:p>
         </p:txBody>
       </p:sp>
@@ -15929,12 +15944,12 @@
               <a:buChar char="q"/>
             </a:pPr>
             <a:r>
-              <a:rPr lang="en-US" altLang="ko-KR" sz="1600" b="1" dirty="0">
+              <a:rPr lang="en-US" altLang="ko-KR" sz="1600" dirty="0">
                 <a:ea typeface="맑은 고딕"/>
               </a:rPr>
               <a:t>Flow chart</a:t>
             </a:r>
-            <a:endParaRPr lang="ko-KR" altLang="en-US" sz="1600" b="1" dirty="0">
+            <a:endParaRPr lang="ko-KR" altLang="en-US" sz="1600" dirty="0">
               <a:ea typeface="맑은 고딕"/>
             </a:endParaRPr>
           </a:p>
@@ -18544,7 +18559,7 @@
             <a:pPr algn="ctr"/>
             <a:r>
               <a:rPr lang="ko-KR" altLang="en-US" sz="800" dirty="0"/>
-              <a:t>변경된 댓글 메시지</a:t>
+              <a:t>이슈 연결 메시지</a:t>
             </a:r>
           </a:p>
         </p:txBody>
@@ -18947,7 +18962,7 @@
               <a:buChar char="q"/>
             </a:pPr>
             <a:r>
-              <a:rPr lang="ko-KR" altLang="en-US" sz="1600" b="1" dirty="0">
+              <a:rPr lang="ko-KR" altLang="en-US" sz="1600" dirty="0">
                 <a:ea typeface="맑은 고딕"/>
               </a:rPr>
               <a:t>신규 개발이 필요한 부분은 아래와 같음</a:t>
@@ -19027,27 +19042,48 @@
               <a:rPr lang="ko-KR" altLang="en-US" sz="800" dirty="0">
                 <a:ea typeface="맑은 고딕"/>
               </a:rPr>
-              <a:t>서버에 전달할 이벤트 </a:t>
-            </a:r>
-            <a:r>
-              <a:rPr lang="ko-KR" altLang="en-US" sz="800" dirty="0" err="1">
+              <a:t>서버에 전달할 </a:t>
+            </a:r>
+            <a:r>
+              <a:rPr lang="ko-KR" altLang="en-US" sz="800" b="1" dirty="0">
+                <a:solidFill>
+                  <a:srgbClr val="FF0000"/>
+                </a:solidFill>
+                <a:ea typeface="맑은 고딕"/>
+              </a:rPr>
+              <a:t>이벤트 </a:t>
+            </a:r>
+            <a:r>
+              <a:rPr lang="ko-KR" altLang="en-US" sz="800" b="1" dirty="0" err="1">
+                <a:solidFill>
+                  <a:srgbClr val="FF0000"/>
+                </a:solidFill>
                 <a:ea typeface="맑은 고딕"/>
               </a:rPr>
               <a:t>리스너</a:t>
             </a:r>
             <a:r>
-              <a:rPr lang="en-US" altLang="ko-KR" sz="800" dirty="0">
+              <a:rPr lang="en-US" altLang="ko-KR" sz="800" b="1" dirty="0">
+                <a:solidFill>
+                  <a:srgbClr val="FF0000"/>
+                </a:solidFill>
                 <a:ea typeface="맑은 고딕"/>
               </a:rPr>
               <a:t> </a:t>
             </a:r>
             <a:r>
-              <a:rPr lang="ko-KR" altLang="en-US" sz="800" dirty="0">
+              <a:rPr lang="ko-KR" altLang="en-US" sz="800" b="1" dirty="0">
+                <a:solidFill>
+                  <a:srgbClr val="FF0000"/>
+                </a:solidFill>
                 <a:ea typeface="맑은 고딕"/>
               </a:rPr>
               <a:t>스크립트</a:t>
             </a:r>
-            <a:endParaRPr lang="en-US" altLang="ko-KR" sz="800" dirty="0">
+            <a:endParaRPr lang="en-US" altLang="ko-KR" sz="800" b="1" dirty="0">
+              <a:solidFill>
+                <a:srgbClr val="FF0000"/>
+              </a:solidFill>
               <a:ea typeface="맑은 고딕"/>
             </a:endParaRPr>
           </a:p>
@@ -19105,9 +19141,21 @@
               <a:rPr lang="ko-KR" altLang="en-US" sz="800" dirty="0">
                 <a:ea typeface="맑은 고딕"/>
               </a:rPr>
-              <a:t> 발송 명령을 할 서버 내 스크립트</a:t>
-            </a:r>
-            <a:endParaRPr lang="en-US" altLang="ko-KR" sz="800" dirty="0">
+              <a:t> 발송 명령을 할 </a:t>
+            </a:r>
+            <a:r>
+              <a:rPr lang="ko-KR" altLang="en-US" sz="800" b="1" dirty="0">
+                <a:solidFill>
+                  <a:srgbClr val="FF0000"/>
+                </a:solidFill>
+                <a:ea typeface="맑은 고딕"/>
+              </a:rPr>
+              <a:t>서버 내 스크립트</a:t>
+            </a:r>
+            <a:endParaRPr lang="en-US" altLang="ko-KR" sz="800" b="1" dirty="0">
+              <a:solidFill>
+                <a:srgbClr val="FF0000"/>
+              </a:solidFill>
               <a:ea typeface="맑은 고딕"/>
             </a:endParaRPr>
           </a:p>
@@ -19983,7 +20031,7 @@
               <a:buChar char="q"/>
             </a:pPr>
             <a:r>
-              <a:rPr lang="ko-KR" altLang="en-US" sz="1600" b="1" dirty="0">
+              <a:rPr lang="ko-KR" altLang="en-US" sz="1600" dirty="0">
                 <a:ea typeface="맑은 고딕"/>
               </a:rPr>
               <a:t>프로젝트 내에서 가장 많이 쓰이는 이벤트만 알림 발송 예정</a:t>
@@ -20093,9 +20141,23 @@
               <a:rPr lang="ko-KR" altLang="en-US" sz="800" dirty="0">
                 <a:ea typeface="맑은 고딕"/>
               </a:rPr>
-              <a:t> 알림 발송 예정</a:t>
-            </a:r>
-            <a:endParaRPr lang="en-US" altLang="ko-KR" sz="800" dirty="0">
+              <a:t> 알림 발송 예정 </a:t>
+            </a:r>
+            <a:r>
+              <a:rPr lang="en-US" altLang="ko-KR" sz="800" dirty="0">
+                <a:ea typeface="맑은 고딕"/>
+                <a:sym typeface="Wingdings" panose="05000000000000000000" pitchFamily="2" charset="2"/>
+              </a:rPr>
+              <a:t> </a:t>
+            </a:r>
+            <a:r>
+              <a:rPr lang="ko-KR" altLang="en-US" sz="800" b="1" dirty="0">
+                <a:ea typeface="맑은 고딕"/>
+                <a:sym typeface="Wingdings" panose="05000000000000000000" pitchFamily="2" charset="2"/>
+              </a:rPr>
+              <a:t>너무 많은 케이스에 발송할 경우 스팸화 우려</a:t>
+            </a:r>
+            <a:endParaRPr lang="en-US" altLang="ko-KR" sz="800" b="1" dirty="0">
               <a:ea typeface="맑은 고딕"/>
             </a:endParaRPr>
           </a:p>

</xml_diff>